<commit_message>
Updated comics Attribute Types and Central Tendency
</commit_message>
<xml_diff>
--- a/Comixplain_Editions/Attribute Types/PowerPoint/Comixplain - Datenattribute DE.pptx
+++ b/Comixplain_Editions/Attribute Types/PowerPoint/Comixplain - Datenattribute DE.pptx
@@ -221,7 +221,7 @@
 <file path=ppt/revisionInfo.xml><?xml version="1.0" encoding="utf-8"?>
 <p1510:revInfo xmlns:a="http://schemas.openxmlformats.org/drawingml/2006/main" xmlns:r="http://schemas.openxmlformats.org/officeDocument/2006/relationships" xmlns:p1510="http://schemas.microsoft.com/office/powerpoint/2015/10/main">
   <p1510:revLst>
-    <p1510:client id="{7EDCBF64-382A-4920-AB61-BF210E65454D}" v="19" dt="2025-11-08T13:41:52.635"/>
+    <p1510:client id="{7EDCBF64-382A-4920-AB61-BF210E65454D}" v="23" dt="2025-11-09T06:53:50.442"/>
   </p1510:revLst>
 </p1510:revInfo>
 </file>
@@ -231,7 +231,7 @@
   <pc:docChgLst>
     <pc:chgData name="de-Jesus-Oliveira Victor-Adriel" userId="a708fc36-3c1b-42ab-b5e9-2e1fa3c6605e" providerId="ADAL" clId="{39AA12F0-CB51-4D67-A3A6-7C3EC2C345CA}"/>
     <pc:docChg chg="custSel modSld">
-      <pc:chgData name="de-Jesus-Oliveira Victor-Adriel" userId="a708fc36-3c1b-42ab-b5e9-2e1fa3c6605e" providerId="ADAL" clId="{39AA12F0-CB51-4D67-A3A6-7C3EC2C345CA}" dt="2025-11-08T13:41:52.634" v="31"/>
+      <pc:chgData name="de-Jesus-Oliveira Victor-Adriel" userId="a708fc36-3c1b-42ab-b5e9-2e1fa3c6605e" providerId="ADAL" clId="{39AA12F0-CB51-4D67-A3A6-7C3EC2C345CA}" dt="2025-11-09T06:54:10.217" v="47" actId="478"/>
       <pc:docMkLst>
         <pc:docMk/>
       </pc:docMkLst>
@@ -247,14 +247,6 @@
             <pc:docMk/>
             <pc:sldMk cId="1717017816" sldId="266"/>
             <ac:spMk id="2" creationId="{36F7C832-7D7F-40CB-9479-79BC46A793B9}"/>
-          </ac:spMkLst>
-        </pc:spChg>
-        <pc:spChg chg="del">
-          <ac:chgData name="de-Jesus-Oliveira Victor-Adriel" userId="a708fc36-3c1b-42ab-b5e9-2e1fa3c6605e" providerId="ADAL" clId="{39AA12F0-CB51-4D67-A3A6-7C3EC2C345CA}" dt="2025-11-07T10:34:24.259" v="9" actId="478"/>
-          <ac:spMkLst>
-            <pc:docMk/>
-            <pc:sldMk cId="1717017816" sldId="266"/>
-            <ac:spMk id="3" creationId="{C8EFDA5B-0D59-E3EF-BF0F-32745B8C48C4}"/>
           </ac:spMkLst>
         </pc:spChg>
         <pc:spChg chg="add mod">
@@ -289,22 +281,6 @@
             <ac:grpSpMk id="12" creationId="{82A85E91-6509-7E3C-B174-616ABEA642EB}"/>
           </ac:grpSpMkLst>
         </pc:grpChg>
-        <pc:picChg chg="del">
-          <ac:chgData name="de-Jesus-Oliveira Victor-Adriel" userId="a708fc36-3c1b-42ab-b5e9-2e1fa3c6605e" providerId="ADAL" clId="{39AA12F0-CB51-4D67-A3A6-7C3EC2C345CA}" dt="2025-11-07T10:32:29.872" v="6" actId="478"/>
-          <ac:picMkLst>
-            <pc:docMk/>
-            <pc:sldMk cId="1717017816" sldId="266"/>
-            <ac:picMk id="4" creationId="{2EB10971-A7A0-4F60-8D4A-4B8950F4D157}"/>
-          </ac:picMkLst>
-        </pc:picChg>
-        <pc:picChg chg="del">
-          <ac:chgData name="de-Jesus-Oliveira Victor-Adriel" userId="a708fc36-3c1b-42ab-b5e9-2e1fa3c6605e" providerId="ADAL" clId="{39AA12F0-CB51-4D67-A3A6-7C3EC2C345CA}" dt="2025-11-07T10:34:22.985" v="8" actId="478"/>
-          <ac:picMkLst>
-            <pc:docMk/>
-            <pc:sldMk cId="1717017816" sldId="266"/>
-            <ac:picMk id="5" creationId="{54F8D709-597E-A9E2-C4CD-741636268425}"/>
-          </ac:picMkLst>
-        </pc:picChg>
         <pc:picChg chg="mod">
           <ac:chgData name="de-Jesus-Oliveira Victor-Adriel" userId="a708fc36-3c1b-42ab-b5e9-2e1fa3c6605e" providerId="ADAL" clId="{39AA12F0-CB51-4D67-A3A6-7C3EC2C345CA}" dt="2025-11-07T10:33:39.318" v="7"/>
           <ac:picMkLst>
@@ -377,14 +353,14 @@
           </ac:picMkLst>
         </pc:picChg>
       </pc:sldChg>
-      <pc:sldChg chg="addSp modSp">
-        <pc:chgData name="de-Jesus-Oliveira Victor-Adriel" userId="a708fc36-3c1b-42ab-b5e9-2e1fa3c6605e" providerId="ADAL" clId="{39AA12F0-CB51-4D67-A3A6-7C3EC2C345CA}" dt="2025-11-08T13:41:44.624" v="28"/>
+      <pc:sldChg chg="addSp delSp modSp mod">
+        <pc:chgData name="de-Jesus-Oliveira Victor-Adriel" userId="a708fc36-3c1b-42ab-b5e9-2e1fa3c6605e" providerId="ADAL" clId="{39AA12F0-CB51-4D67-A3A6-7C3EC2C345CA}" dt="2025-11-09T06:54:10.217" v="47" actId="478"/>
         <pc:sldMkLst>
           <pc:docMk/>
           <pc:sldMk cId="3413901204" sldId="270"/>
         </pc:sldMkLst>
-        <pc:grpChg chg="add mod">
-          <ac:chgData name="de-Jesus-Oliveira Victor-Adriel" userId="a708fc36-3c1b-42ab-b5e9-2e1fa3c6605e" providerId="ADAL" clId="{39AA12F0-CB51-4D67-A3A6-7C3EC2C345CA}" dt="2025-11-08T13:41:44.624" v="28"/>
+        <pc:grpChg chg="add del mod">
+          <ac:chgData name="de-Jesus-Oliveira Victor-Adriel" userId="a708fc36-3c1b-42ab-b5e9-2e1fa3c6605e" providerId="ADAL" clId="{39AA12F0-CB51-4D67-A3A6-7C3EC2C345CA}" dt="2025-11-09T06:54:10.217" v="47" actId="478"/>
           <ac:grpSpMkLst>
             <pc:docMk/>
             <pc:sldMk cId="3413901204" sldId="270"/>
@@ -397,6 +373,22 @@
             <pc:docMk/>
             <pc:sldMk cId="3413901204" sldId="270"/>
             <ac:grpSpMk id="18" creationId="{99BF9F96-A84B-9BB9-C211-EA57DE2678A3}"/>
+          </ac:grpSpMkLst>
+        </pc:grpChg>
+        <pc:grpChg chg="add mod">
+          <ac:chgData name="de-Jesus-Oliveira Victor-Adriel" userId="a708fc36-3c1b-42ab-b5e9-2e1fa3c6605e" providerId="ADAL" clId="{39AA12F0-CB51-4D67-A3A6-7C3EC2C345CA}" dt="2025-11-09T06:53:23.313" v="40" actId="1035"/>
+          <ac:grpSpMkLst>
+            <pc:docMk/>
+            <pc:sldMk cId="3413901204" sldId="270"/>
+            <ac:grpSpMk id="22" creationId="{0CF2EDFA-3793-81DF-E297-68D19DBAAA97}"/>
+          </ac:grpSpMkLst>
+        </pc:grpChg>
+        <pc:grpChg chg="mod">
+          <ac:chgData name="de-Jesus-Oliveira Victor-Adriel" userId="a708fc36-3c1b-42ab-b5e9-2e1fa3c6605e" providerId="ADAL" clId="{39AA12F0-CB51-4D67-A3A6-7C3EC2C345CA}" dt="2025-11-09T06:53:06.152" v="32"/>
+          <ac:grpSpMkLst>
+            <pc:docMk/>
+            <pc:sldMk cId="3413901204" sldId="270"/>
+            <ac:grpSpMk id="24" creationId="{036CC775-C303-86A1-C75F-5D18D1CA370D}"/>
           </ac:grpSpMkLst>
         </pc:grpChg>
         <pc:picChg chg="mod">
@@ -431,15 +423,47 @@
             <ac:picMk id="21" creationId="{C4C61D37-1385-28E9-868D-9844B899C9B7}"/>
           </ac:picMkLst>
         </pc:picChg>
+        <pc:picChg chg="mod">
+          <ac:chgData name="de-Jesus-Oliveira Victor-Adriel" userId="a708fc36-3c1b-42ab-b5e9-2e1fa3c6605e" providerId="ADAL" clId="{39AA12F0-CB51-4D67-A3A6-7C3EC2C345CA}" dt="2025-11-09T06:53:06.152" v="32"/>
+          <ac:picMkLst>
+            <pc:docMk/>
+            <pc:sldMk cId="3413901204" sldId="270"/>
+            <ac:picMk id="23" creationId="{FA6AECFD-C72F-3D03-AEAC-348F84AF6491}"/>
+          </ac:picMkLst>
+        </pc:picChg>
+        <pc:picChg chg="mod">
+          <ac:chgData name="de-Jesus-Oliveira Victor-Adriel" userId="a708fc36-3c1b-42ab-b5e9-2e1fa3c6605e" providerId="ADAL" clId="{39AA12F0-CB51-4D67-A3A6-7C3EC2C345CA}" dt="2025-11-09T06:53:06.152" v="32"/>
+          <ac:picMkLst>
+            <pc:docMk/>
+            <pc:sldMk cId="3413901204" sldId="270"/>
+            <ac:picMk id="25" creationId="{AF214B8C-C025-C7E8-1396-82E953EE76AC}"/>
+          </ac:picMkLst>
+        </pc:picChg>
+        <pc:picChg chg="mod">
+          <ac:chgData name="de-Jesus-Oliveira Victor-Adriel" userId="a708fc36-3c1b-42ab-b5e9-2e1fa3c6605e" providerId="ADAL" clId="{39AA12F0-CB51-4D67-A3A6-7C3EC2C345CA}" dt="2025-11-09T06:53:06.152" v="32"/>
+          <ac:picMkLst>
+            <pc:docMk/>
+            <pc:sldMk cId="3413901204" sldId="270"/>
+            <ac:picMk id="26" creationId="{CB69A6AF-635D-1988-2D67-648EF1FC7D2D}"/>
+          </ac:picMkLst>
+        </pc:picChg>
+        <pc:picChg chg="mod">
+          <ac:chgData name="de-Jesus-Oliveira Victor-Adriel" userId="a708fc36-3c1b-42ab-b5e9-2e1fa3c6605e" providerId="ADAL" clId="{39AA12F0-CB51-4D67-A3A6-7C3EC2C345CA}" dt="2025-11-09T06:53:06.152" v="32"/>
+          <ac:picMkLst>
+            <pc:docMk/>
+            <pc:sldMk cId="3413901204" sldId="270"/>
+            <ac:picMk id="27" creationId="{2A1917DC-8EE2-517C-0F63-BB6A07598A43}"/>
+          </ac:picMkLst>
+        </pc:picChg>
       </pc:sldChg>
-      <pc:sldChg chg="addSp modSp">
-        <pc:chgData name="de-Jesus-Oliveira Victor-Adriel" userId="a708fc36-3c1b-42ab-b5e9-2e1fa3c6605e" providerId="ADAL" clId="{39AA12F0-CB51-4D67-A3A6-7C3EC2C345CA}" dt="2025-11-08T13:41:46.700" v="29"/>
+      <pc:sldChg chg="addSp delSp modSp mod">
+        <pc:chgData name="de-Jesus-Oliveira Victor-Adriel" userId="a708fc36-3c1b-42ab-b5e9-2e1fa3c6605e" providerId="ADAL" clId="{39AA12F0-CB51-4D67-A3A6-7C3EC2C345CA}" dt="2025-11-09T06:54:06.950" v="46" actId="478"/>
         <pc:sldMkLst>
           <pc:docMk/>
           <pc:sldMk cId="3421718116" sldId="271"/>
         </pc:sldMkLst>
-        <pc:grpChg chg="add mod">
-          <ac:chgData name="de-Jesus-Oliveira Victor-Adriel" userId="a708fc36-3c1b-42ab-b5e9-2e1fa3c6605e" providerId="ADAL" clId="{39AA12F0-CB51-4D67-A3A6-7C3EC2C345CA}" dt="2025-11-08T13:41:46.700" v="29"/>
+        <pc:grpChg chg="add del mod">
+          <ac:chgData name="de-Jesus-Oliveira Victor-Adriel" userId="a708fc36-3c1b-42ab-b5e9-2e1fa3c6605e" providerId="ADAL" clId="{39AA12F0-CB51-4D67-A3A6-7C3EC2C345CA}" dt="2025-11-09T06:54:06.950" v="46" actId="478"/>
           <ac:grpSpMkLst>
             <pc:docMk/>
             <pc:sldMk cId="3421718116" sldId="271"/>
@@ -452,6 +476,22 @@
             <pc:docMk/>
             <pc:sldMk cId="3421718116" sldId="271"/>
             <ac:grpSpMk id="31" creationId="{DDA9A306-57AF-8DD3-1688-5E3302D0891D}"/>
+          </ac:grpSpMkLst>
+        </pc:grpChg>
+        <pc:grpChg chg="add mod">
+          <ac:chgData name="de-Jesus-Oliveira Victor-Adriel" userId="a708fc36-3c1b-42ab-b5e9-2e1fa3c6605e" providerId="ADAL" clId="{39AA12F0-CB51-4D67-A3A6-7C3EC2C345CA}" dt="2025-11-09T06:53:46.981" v="41"/>
+          <ac:grpSpMkLst>
+            <pc:docMk/>
+            <pc:sldMk cId="3421718116" sldId="271"/>
+            <ac:grpSpMk id="35" creationId="{3E92ED56-C8F5-CFD3-C723-96CC16630C30}"/>
+          </ac:grpSpMkLst>
+        </pc:grpChg>
+        <pc:grpChg chg="mod">
+          <ac:chgData name="de-Jesus-Oliveira Victor-Adriel" userId="a708fc36-3c1b-42ab-b5e9-2e1fa3c6605e" providerId="ADAL" clId="{39AA12F0-CB51-4D67-A3A6-7C3EC2C345CA}" dt="2025-11-09T06:53:46.981" v="41"/>
+          <ac:grpSpMkLst>
+            <pc:docMk/>
+            <pc:sldMk cId="3421718116" sldId="271"/>
+            <ac:grpSpMk id="37" creationId="{E6213FE8-67DD-968B-D2CF-D0C3BF430F95}"/>
           </ac:grpSpMkLst>
         </pc:grpChg>
         <pc:picChg chg="mod">
@@ -486,15 +526,47 @@
             <ac:picMk id="34" creationId="{0EB7CB5A-A1DC-790A-6912-F9F8EB5B7BA6}"/>
           </ac:picMkLst>
         </pc:picChg>
+        <pc:picChg chg="mod">
+          <ac:chgData name="de-Jesus-Oliveira Victor-Adriel" userId="a708fc36-3c1b-42ab-b5e9-2e1fa3c6605e" providerId="ADAL" clId="{39AA12F0-CB51-4D67-A3A6-7C3EC2C345CA}" dt="2025-11-09T06:53:46.981" v="41"/>
+          <ac:picMkLst>
+            <pc:docMk/>
+            <pc:sldMk cId="3421718116" sldId="271"/>
+            <ac:picMk id="36" creationId="{B26E2D6C-CF9B-B327-0930-27598F435701}"/>
+          </ac:picMkLst>
+        </pc:picChg>
+        <pc:picChg chg="mod">
+          <ac:chgData name="de-Jesus-Oliveira Victor-Adriel" userId="a708fc36-3c1b-42ab-b5e9-2e1fa3c6605e" providerId="ADAL" clId="{39AA12F0-CB51-4D67-A3A6-7C3EC2C345CA}" dt="2025-11-09T06:53:46.981" v="41"/>
+          <ac:picMkLst>
+            <pc:docMk/>
+            <pc:sldMk cId="3421718116" sldId="271"/>
+            <ac:picMk id="38" creationId="{BA99970C-340B-666F-A12D-6C57A86B46D0}"/>
+          </ac:picMkLst>
+        </pc:picChg>
+        <pc:picChg chg="mod">
+          <ac:chgData name="de-Jesus-Oliveira Victor-Adriel" userId="a708fc36-3c1b-42ab-b5e9-2e1fa3c6605e" providerId="ADAL" clId="{39AA12F0-CB51-4D67-A3A6-7C3EC2C345CA}" dt="2025-11-09T06:53:46.981" v="41"/>
+          <ac:picMkLst>
+            <pc:docMk/>
+            <pc:sldMk cId="3421718116" sldId="271"/>
+            <ac:picMk id="39" creationId="{875A85D1-1626-4CF5-0CEC-24E2E2ED457C}"/>
+          </ac:picMkLst>
+        </pc:picChg>
+        <pc:picChg chg="mod">
+          <ac:chgData name="de-Jesus-Oliveira Victor-Adriel" userId="a708fc36-3c1b-42ab-b5e9-2e1fa3c6605e" providerId="ADAL" clId="{39AA12F0-CB51-4D67-A3A6-7C3EC2C345CA}" dt="2025-11-09T06:53:46.981" v="41"/>
+          <ac:picMkLst>
+            <pc:docMk/>
+            <pc:sldMk cId="3421718116" sldId="271"/>
+            <ac:picMk id="40" creationId="{584E6BC5-6475-A8D1-5888-00B7FA876CDD}"/>
+          </ac:picMkLst>
+        </pc:picChg>
       </pc:sldChg>
-      <pc:sldChg chg="addSp modSp">
-        <pc:chgData name="de-Jesus-Oliveira Victor-Adriel" userId="a708fc36-3c1b-42ab-b5e9-2e1fa3c6605e" providerId="ADAL" clId="{39AA12F0-CB51-4D67-A3A6-7C3EC2C345CA}" dt="2025-11-08T13:41:49.345" v="30"/>
+      <pc:sldChg chg="addSp delSp modSp mod">
+        <pc:chgData name="de-Jesus-Oliveira Victor-Adriel" userId="a708fc36-3c1b-42ab-b5e9-2e1fa3c6605e" providerId="ADAL" clId="{39AA12F0-CB51-4D67-A3A6-7C3EC2C345CA}" dt="2025-11-09T06:54:04.100" v="45" actId="478"/>
         <pc:sldMkLst>
           <pc:docMk/>
           <pc:sldMk cId="483493654" sldId="272"/>
         </pc:sldMkLst>
-        <pc:grpChg chg="add mod">
-          <ac:chgData name="de-Jesus-Oliveira Victor-Adriel" userId="a708fc36-3c1b-42ab-b5e9-2e1fa3c6605e" providerId="ADAL" clId="{39AA12F0-CB51-4D67-A3A6-7C3EC2C345CA}" dt="2025-11-08T13:41:49.345" v="30"/>
+        <pc:grpChg chg="add del mod">
+          <ac:chgData name="de-Jesus-Oliveira Victor-Adriel" userId="a708fc36-3c1b-42ab-b5e9-2e1fa3c6605e" providerId="ADAL" clId="{39AA12F0-CB51-4D67-A3A6-7C3EC2C345CA}" dt="2025-11-09T06:54:04.100" v="45" actId="478"/>
           <ac:grpSpMkLst>
             <pc:docMk/>
             <pc:sldMk cId="483493654" sldId="272"/>
@@ -507,6 +579,22 @@
             <pc:docMk/>
             <pc:sldMk cId="483493654" sldId="272"/>
             <ac:grpSpMk id="23" creationId="{55A46F05-4DB7-5D63-1824-3657FB16D564}"/>
+          </ac:grpSpMkLst>
+        </pc:grpChg>
+        <pc:grpChg chg="add mod">
+          <ac:chgData name="de-Jesus-Oliveira Victor-Adriel" userId="a708fc36-3c1b-42ab-b5e9-2e1fa3c6605e" providerId="ADAL" clId="{39AA12F0-CB51-4D67-A3A6-7C3EC2C345CA}" dt="2025-11-09T06:53:49.007" v="42"/>
+          <ac:grpSpMkLst>
+            <pc:docMk/>
+            <pc:sldMk cId="483493654" sldId="272"/>
+            <ac:grpSpMk id="27" creationId="{59D64B8B-3BE8-9B29-CE71-21B765E22BF5}"/>
+          </ac:grpSpMkLst>
+        </pc:grpChg>
+        <pc:grpChg chg="mod">
+          <ac:chgData name="de-Jesus-Oliveira Victor-Adriel" userId="a708fc36-3c1b-42ab-b5e9-2e1fa3c6605e" providerId="ADAL" clId="{39AA12F0-CB51-4D67-A3A6-7C3EC2C345CA}" dt="2025-11-09T06:53:49.007" v="42"/>
+          <ac:grpSpMkLst>
+            <pc:docMk/>
+            <pc:sldMk cId="483493654" sldId="272"/>
+            <ac:grpSpMk id="29" creationId="{25468CBA-47B9-943E-6F16-AB244B799FA0}"/>
           </ac:grpSpMkLst>
         </pc:grpChg>
         <pc:picChg chg="mod">
@@ -541,15 +629,47 @@
             <ac:picMk id="26" creationId="{7D001D33-4752-A77A-83E8-A907A2D78282}"/>
           </ac:picMkLst>
         </pc:picChg>
+        <pc:picChg chg="mod">
+          <ac:chgData name="de-Jesus-Oliveira Victor-Adriel" userId="a708fc36-3c1b-42ab-b5e9-2e1fa3c6605e" providerId="ADAL" clId="{39AA12F0-CB51-4D67-A3A6-7C3EC2C345CA}" dt="2025-11-09T06:53:49.007" v="42"/>
+          <ac:picMkLst>
+            <pc:docMk/>
+            <pc:sldMk cId="483493654" sldId="272"/>
+            <ac:picMk id="28" creationId="{DB493EE4-26F2-304E-5349-5D61B8EB313B}"/>
+          </ac:picMkLst>
+        </pc:picChg>
+        <pc:picChg chg="mod">
+          <ac:chgData name="de-Jesus-Oliveira Victor-Adriel" userId="a708fc36-3c1b-42ab-b5e9-2e1fa3c6605e" providerId="ADAL" clId="{39AA12F0-CB51-4D67-A3A6-7C3EC2C345CA}" dt="2025-11-09T06:53:49.007" v="42"/>
+          <ac:picMkLst>
+            <pc:docMk/>
+            <pc:sldMk cId="483493654" sldId="272"/>
+            <ac:picMk id="30" creationId="{F87A6AFA-73EA-424C-EF17-1D268F761A7A}"/>
+          </ac:picMkLst>
+        </pc:picChg>
+        <pc:picChg chg="mod">
+          <ac:chgData name="de-Jesus-Oliveira Victor-Adriel" userId="a708fc36-3c1b-42ab-b5e9-2e1fa3c6605e" providerId="ADAL" clId="{39AA12F0-CB51-4D67-A3A6-7C3EC2C345CA}" dt="2025-11-09T06:53:49.007" v="42"/>
+          <ac:picMkLst>
+            <pc:docMk/>
+            <pc:sldMk cId="483493654" sldId="272"/>
+            <ac:picMk id="31" creationId="{4F97DE03-1C2A-0F34-A473-BEA2F6ACA809}"/>
+          </ac:picMkLst>
+        </pc:picChg>
+        <pc:picChg chg="mod">
+          <ac:chgData name="de-Jesus-Oliveira Victor-Adriel" userId="a708fc36-3c1b-42ab-b5e9-2e1fa3c6605e" providerId="ADAL" clId="{39AA12F0-CB51-4D67-A3A6-7C3EC2C345CA}" dt="2025-11-09T06:53:49.007" v="42"/>
+          <ac:picMkLst>
+            <pc:docMk/>
+            <pc:sldMk cId="483493654" sldId="272"/>
+            <ac:picMk id="32" creationId="{5AB9180D-FED1-5990-49F3-4924A43AF039}"/>
+          </ac:picMkLst>
+        </pc:picChg>
       </pc:sldChg>
-      <pc:sldChg chg="addSp modSp">
-        <pc:chgData name="de-Jesus-Oliveira Victor-Adriel" userId="a708fc36-3c1b-42ab-b5e9-2e1fa3c6605e" providerId="ADAL" clId="{39AA12F0-CB51-4D67-A3A6-7C3EC2C345CA}" dt="2025-11-08T13:41:52.634" v="31"/>
+      <pc:sldChg chg="addSp delSp modSp mod">
+        <pc:chgData name="de-Jesus-Oliveira Victor-Adriel" userId="a708fc36-3c1b-42ab-b5e9-2e1fa3c6605e" providerId="ADAL" clId="{39AA12F0-CB51-4D67-A3A6-7C3EC2C345CA}" dt="2025-11-09T06:54:00.269" v="44" actId="478"/>
         <pc:sldMkLst>
           <pc:docMk/>
           <pc:sldMk cId="1849523182" sldId="273"/>
         </pc:sldMkLst>
-        <pc:grpChg chg="add mod">
-          <ac:chgData name="de-Jesus-Oliveira Victor-Adriel" userId="a708fc36-3c1b-42ab-b5e9-2e1fa3c6605e" providerId="ADAL" clId="{39AA12F0-CB51-4D67-A3A6-7C3EC2C345CA}" dt="2025-11-08T13:41:52.634" v="31"/>
+        <pc:grpChg chg="add del mod">
+          <ac:chgData name="de-Jesus-Oliveira Victor-Adriel" userId="a708fc36-3c1b-42ab-b5e9-2e1fa3c6605e" providerId="ADAL" clId="{39AA12F0-CB51-4D67-A3A6-7C3EC2C345CA}" dt="2025-11-09T06:54:00.269" v="44" actId="478"/>
           <ac:grpSpMkLst>
             <pc:docMk/>
             <pc:sldMk cId="1849523182" sldId="273"/>
@@ -562,6 +682,22 @@
             <pc:docMk/>
             <pc:sldMk cId="1849523182" sldId="273"/>
             <ac:grpSpMk id="11" creationId="{919F3083-E189-5940-EBA5-0C16C2C2BC68}"/>
+          </ac:grpSpMkLst>
+        </pc:grpChg>
+        <pc:grpChg chg="add mod">
+          <ac:chgData name="de-Jesus-Oliveira Victor-Adriel" userId="a708fc36-3c1b-42ab-b5e9-2e1fa3c6605e" providerId="ADAL" clId="{39AA12F0-CB51-4D67-A3A6-7C3EC2C345CA}" dt="2025-11-09T06:53:50.442" v="43"/>
+          <ac:grpSpMkLst>
+            <pc:docMk/>
+            <pc:sldMk cId="1849523182" sldId="273"/>
+            <ac:grpSpMk id="15" creationId="{5E2555FA-EB1C-5ABA-4CFC-B47503D6F393}"/>
+          </ac:grpSpMkLst>
+        </pc:grpChg>
+        <pc:grpChg chg="mod">
+          <ac:chgData name="de-Jesus-Oliveira Victor-Adriel" userId="a708fc36-3c1b-42ab-b5e9-2e1fa3c6605e" providerId="ADAL" clId="{39AA12F0-CB51-4D67-A3A6-7C3EC2C345CA}" dt="2025-11-09T06:53:50.442" v="43"/>
+          <ac:grpSpMkLst>
+            <pc:docMk/>
+            <pc:sldMk cId="1849523182" sldId="273"/>
+            <ac:grpSpMk id="17" creationId="{263B43C7-ED10-BA2F-F7E4-6870680F946C}"/>
           </ac:grpSpMkLst>
         </pc:grpChg>
         <pc:picChg chg="mod">
@@ -594,6 +730,38 @@
             <pc:docMk/>
             <pc:sldMk cId="1849523182" sldId="273"/>
             <ac:picMk id="14" creationId="{7644ECFB-139C-2D96-9E8B-48B1F3220AEF}"/>
+          </ac:picMkLst>
+        </pc:picChg>
+        <pc:picChg chg="mod">
+          <ac:chgData name="de-Jesus-Oliveira Victor-Adriel" userId="a708fc36-3c1b-42ab-b5e9-2e1fa3c6605e" providerId="ADAL" clId="{39AA12F0-CB51-4D67-A3A6-7C3EC2C345CA}" dt="2025-11-09T06:53:50.442" v="43"/>
+          <ac:picMkLst>
+            <pc:docMk/>
+            <pc:sldMk cId="1849523182" sldId="273"/>
+            <ac:picMk id="16" creationId="{78313FCB-D2E6-ED59-D9EF-28395F98C9EF}"/>
+          </ac:picMkLst>
+        </pc:picChg>
+        <pc:picChg chg="mod">
+          <ac:chgData name="de-Jesus-Oliveira Victor-Adriel" userId="a708fc36-3c1b-42ab-b5e9-2e1fa3c6605e" providerId="ADAL" clId="{39AA12F0-CB51-4D67-A3A6-7C3EC2C345CA}" dt="2025-11-09T06:53:50.442" v="43"/>
+          <ac:picMkLst>
+            <pc:docMk/>
+            <pc:sldMk cId="1849523182" sldId="273"/>
+            <ac:picMk id="18" creationId="{3A437B38-3056-10E3-B300-5E49CE1608C3}"/>
+          </ac:picMkLst>
+        </pc:picChg>
+        <pc:picChg chg="mod">
+          <ac:chgData name="de-Jesus-Oliveira Victor-Adriel" userId="a708fc36-3c1b-42ab-b5e9-2e1fa3c6605e" providerId="ADAL" clId="{39AA12F0-CB51-4D67-A3A6-7C3EC2C345CA}" dt="2025-11-09T06:53:50.442" v="43"/>
+          <ac:picMkLst>
+            <pc:docMk/>
+            <pc:sldMk cId="1849523182" sldId="273"/>
+            <ac:picMk id="19" creationId="{4BE9FBC5-DD26-DC12-ABB1-0D742F035C7C}"/>
+          </ac:picMkLst>
+        </pc:picChg>
+        <pc:picChg chg="mod">
+          <ac:chgData name="de-Jesus-Oliveira Victor-Adriel" userId="a708fc36-3c1b-42ab-b5e9-2e1fa3c6605e" providerId="ADAL" clId="{39AA12F0-CB51-4D67-A3A6-7C3EC2C345CA}" dt="2025-11-09T06:53:50.442" v="43"/>
+          <ac:picMkLst>
+            <pc:docMk/>
+            <pc:sldMk cId="1849523182" sldId="273"/>
+            <ac:picMk id="20" creationId="{D4267AC5-DD00-75C1-DF8F-82D64536605D}"/>
           </ac:picMkLst>
         </pc:picChg>
       </pc:sldChg>
@@ -733,7 +901,7 @@
           <a:p>
             <a:fld id="{54B5A053-06E9-40EE-BE46-DB75A413985D}" type="datetimeFigureOut">
               <a:rPr lang="de-AT" smtClean="0"/>
-              <a:t>08.11.2025</a:t>
+              <a:t>09.11.2025</a:t>
             </a:fld>
             <a:endParaRPr lang="de-AT"/>
           </a:p>
@@ -903,7 +1071,7 @@
           <a:p>
             <a:fld id="{54B5A053-06E9-40EE-BE46-DB75A413985D}" type="datetimeFigureOut">
               <a:rPr lang="de-AT" smtClean="0"/>
-              <a:t>08.11.2025</a:t>
+              <a:t>09.11.2025</a:t>
             </a:fld>
             <a:endParaRPr lang="de-AT"/>
           </a:p>
@@ -1083,7 +1251,7 @@
           <a:p>
             <a:fld id="{54B5A053-06E9-40EE-BE46-DB75A413985D}" type="datetimeFigureOut">
               <a:rPr lang="de-AT" smtClean="0"/>
-              <a:t>08.11.2025</a:t>
+              <a:t>09.11.2025</a:t>
             </a:fld>
             <a:endParaRPr lang="de-AT"/>
           </a:p>
@@ -1253,7 +1421,7 @@
           <a:p>
             <a:fld id="{54B5A053-06E9-40EE-BE46-DB75A413985D}" type="datetimeFigureOut">
               <a:rPr lang="de-AT" smtClean="0"/>
-              <a:t>08.11.2025</a:t>
+              <a:t>09.11.2025</a:t>
             </a:fld>
             <a:endParaRPr lang="de-AT"/>
           </a:p>
@@ -1497,7 +1665,7 @@
           <a:p>
             <a:fld id="{54B5A053-06E9-40EE-BE46-DB75A413985D}" type="datetimeFigureOut">
               <a:rPr lang="de-AT" smtClean="0"/>
-              <a:t>08.11.2025</a:t>
+              <a:t>09.11.2025</a:t>
             </a:fld>
             <a:endParaRPr lang="de-AT"/>
           </a:p>
@@ -1729,7 +1897,7 @@
           <a:p>
             <a:fld id="{54B5A053-06E9-40EE-BE46-DB75A413985D}" type="datetimeFigureOut">
               <a:rPr lang="de-AT" smtClean="0"/>
-              <a:t>08.11.2025</a:t>
+              <a:t>09.11.2025</a:t>
             </a:fld>
             <a:endParaRPr lang="de-AT"/>
           </a:p>
@@ -2096,7 +2264,7 @@
           <a:p>
             <a:fld id="{54B5A053-06E9-40EE-BE46-DB75A413985D}" type="datetimeFigureOut">
               <a:rPr lang="de-AT" smtClean="0"/>
-              <a:t>08.11.2025</a:t>
+              <a:t>09.11.2025</a:t>
             </a:fld>
             <a:endParaRPr lang="de-AT"/>
           </a:p>
@@ -2214,7 +2382,7 @@
           <a:p>
             <a:fld id="{54B5A053-06E9-40EE-BE46-DB75A413985D}" type="datetimeFigureOut">
               <a:rPr lang="de-AT" smtClean="0"/>
-              <a:t>08.11.2025</a:t>
+              <a:t>09.11.2025</a:t>
             </a:fld>
             <a:endParaRPr lang="de-AT"/>
           </a:p>
@@ -2309,7 +2477,7 @@
           <a:p>
             <a:fld id="{54B5A053-06E9-40EE-BE46-DB75A413985D}" type="datetimeFigureOut">
               <a:rPr lang="de-AT" smtClean="0"/>
-              <a:t>08.11.2025</a:t>
+              <a:t>09.11.2025</a:t>
             </a:fld>
             <a:endParaRPr lang="de-AT"/>
           </a:p>
@@ -2586,7 +2754,7 @@
           <a:p>
             <a:fld id="{54B5A053-06E9-40EE-BE46-DB75A413985D}" type="datetimeFigureOut">
               <a:rPr lang="de-AT" smtClean="0"/>
-              <a:t>08.11.2025</a:t>
+              <a:t>09.11.2025</a:t>
             </a:fld>
             <a:endParaRPr lang="de-AT"/>
           </a:p>
@@ -2843,7 +3011,7 @@
           <a:p>
             <a:fld id="{54B5A053-06E9-40EE-BE46-DB75A413985D}" type="datetimeFigureOut">
               <a:rPr lang="de-AT" smtClean="0"/>
-              <a:t>08.11.2025</a:t>
+              <a:t>09.11.2025</a:t>
             </a:fld>
             <a:endParaRPr lang="de-AT"/>
           </a:p>
@@ -3066,7 +3234,7 @@
           <a:p>
             <a:fld id="{54B5A053-06E9-40EE-BE46-DB75A413985D}" type="datetimeFigureOut">
               <a:rPr lang="de-AT" smtClean="0"/>
-              <a:t>08.11.2025</a:t>
+              <a:t>09.11.2025</a:t>
             </a:fld>
             <a:endParaRPr lang="de-AT"/>
           </a:p>
@@ -9877,10 +10045,10 @@
       </p:sp>
       <p:grpSp>
         <p:nvGrpSpPr>
-          <p:cNvPr id="16" name="Group 15">
+          <p:cNvPr id="22" name="Group 21">
             <a:extLst>
               <a:ext uri="{FF2B5EF4-FFF2-40B4-BE49-F238E27FC236}">
-                <a16:creationId xmlns:a16="http://schemas.microsoft.com/office/drawing/2014/main" id="{07F9E236-7DAA-9155-CC9B-76287B5B4945}"/>
+                <a16:creationId xmlns:a16="http://schemas.microsoft.com/office/drawing/2014/main" id="{0CF2EDFA-3793-81DF-E297-68D19DBAAA97}"/>
               </a:ext>
               <a:ext uri="{C183D7F6-B498-43B3-948B-1728B52AA6E4}">
                 <adec:decorative xmlns:adec="http://schemas.microsoft.com/office/drawing/2017/decorative" val="1"/>
@@ -9892,18 +10060,18 @@
         </p:nvGrpSpPr>
         <p:grpSpPr>
           <a:xfrm>
-            <a:off x="295910" y="9653937"/>
-            <a:ext cx="1305101" cy="163205"/>
+            <a:off x="5250199" y="245911"/>
+            <a:ext cx="1305102" cy="163205"/>
             <a:chOff x="295910" y="9653937"/>
-            <a:chExt cx="1305101" cy="163205"/>
+            <a:chExt cx="1305102" cy="163205"/>
           </a:xfrm>
         </p:grpSpPr>
         <p:pic>
           <p:nvPicPr>
-            <p:cNvPr id="17" name="Picture 16">
+            <p:cNvPr id="23" name="Picture 22">
               <a:extLst>
                 <a:ext uri="{FF2B5EF4-FFF2-40B4-BE49-F238E27FC236}">
-                  <a16:creationId xmlns:a16="http://schemas.microsoft.com/office/drawing/2014/main" id="{A3978DA0-D4C4-FA14-CA97-F69DCD1A3453}"/>
+                  <a16:creationId xmlns:a16="http://schemas.microsoft.com/office/drawing/2014/main" id="{FA6AECFD-C72F-3D03-AEAC-348F84AF6491}"/>
                 </a:ext>
                 <a:ext uri="{C183D7F6-B498-43B3-948B-1728B52AA6E4}">
                   <adec:decorative xmlns:adec="http://schemas.microsoft.com/office/drawing/2017/decorative" val="1"/>
@@ -9939,10 +10107,10 @@
         </p:pic>
         <p:grpSp>
           <p:nvGrpSpPr>
-            <p:cNvPr id="18" name="Group 17">
+            <p:cNvPr id="24" name="Group 23">
               <a:extLst>
                 <a:ext uri="{FF2B5EF4-FFF2-40B4-BE49-F238E27FC236}">
-                  <a16:creationId xmlns:a16="http://schemas.microsoft.com/office/drawing/2014/main" id="{99BF9F96-A84B-9BB9-C211-EA57DE2678A3}"/>
+                  <a16:creationId xmlns:a16="http://schemas.microsoft.com/office/drawing/2014/main" id="{036CC775-C303-86A1-C75F-5D18D1CA370D}"/>
                 </a:ext>
                 <a:ext uri="{C183D7F6-B498-43B3-948B-1728B52AA6E4}">
                   <adec:decorative xmlns:adec="http://schemas.microsoft.com/office/drawing/2017/decorative" val="1"/>
@@ -9954,7 +10122,7 @@
           </p:nvGrpSpPr>
           <p:grpSpPr>
             <a:xfrm>
-              <a:off x="1226496" y="9675214"/>
+              <a:off x="1226497" y="9675214"/>
               <a:ext cx="374515" cy="120649"/>
               <a:chOff x="4063999" y="4953000"/>
               <a:chExt cx="1892301" cy="609600"/>
@@ -9962,10 +10130,10 @@
           </p:grpSpPr>
           <p:pic>
             <p:nvPicPr>
-              <p:cNvPr id="19" name="Picture 18">
+              <p:cNvPr id="25" name="Picture 24">
                 <a:extLst>
                   <a:ext uri="{FF2B5EF4-FFF2-40B4-BE49-F238E27FC236}">
-                    <a16:creationId xmlns:a16="http://schemas.microsoft.com/office/drawing/2014/main" id="{B6C9833B-CC91-D16D-982E-B0BF96A65C2A}"/>
+                    <a16:creationId xmlns:a16="http://schemas.microsoft.com/office/drawing/2014/main" id="{AF214B8C-C025-C7E8-1396-82E953EE76AC}"/>
                   </a:ext>
                 </a:extLst>
               </p:cNvPr>
@@ -9992,10 +10160,10 @@
           </p:pic>
           <p:pic>
             <p:nvPicPr>
-              <p:cNvPr id="20" name="Picture 19">
+              <p:cNvPr id="26" name="Picture 25">
                 <a:extLst>
                   <a:ext uri="{FF2B5EF4-FFF2-40B4-BE49-F238E27FC236}">
-                    <a16:creationId xmlns:a16="http://schemas.microsoft.com/office/drawing/2014/main" id="{DA270BD7-762C-2B70-EE33-98CC2B40E646}"/>
+                    <a16:creationId xmlns:a16="http://schemas.microsoft.com/office/drawing/2014/main" id="{CB69A6AF-635D-1988-2D67-648EF1FC7D2D}"/>
                   </a:ext>
                 </a:extLst>
               </p:cNvPr>
@@ -10022,10 +10190,10 @@
           </p:pic>
           <p:pic>
             <p:nvPicPr>
-              <p:cNvPr id="21" name="Picture 20">
+              <p:cNvPr id="27" name="Picture 26">
                 <a:extLst>
                   <a:ext uri="{FF2B5EF4-FFF2-40B4-BE49-F238E27FC236}">
-                    <a16:creationId xmlns:a16="http://schemas.microsoft.com/office/drawing/2014/main" id="{C4C61D37-1385-28E9-868D-9844B899C9B7}"/>
+                    <a16:creationId xmlns:a16="http://schemas.microsoft.com/office/drawing/2014/main" id="{2A1917DC-8EE2-517C-0F63-BB6A07598A43}"/>
                   </a:ext>
                 </a:extLst>
               </p:cNvPr>
@@ -16792,10 +16960,10 @@
       </p:sp>
       <p:grpSp>
         <p:nvGrpSpPr>
-          <p:cNvPr id="29" name="Group 28">
+          <p:cNvPr id="35" name="Group 34">
             <a:extLst>
               <a:ext uri="{FF2B5EF4-FFF2-40B4-BE49-F238E27FC236}">
-                <a16:creationId xmlns:a16="http://schemas.microsoft.com/office/drawing/2014/main" id="{40879D28-897B-0C7B-6579-4E63D5DC7917}"/>
+                <a16:creationId xmlns:a16="http://schemas.microsoft.com/office/drawing/2014/main" id="{3E92ED56-C8F5-CFD3-C723-96CC16630C30}"/>
               </a:ext>
               <a:ext uri="{C183D7F6-B498-43B3-948B-1728B52AA6E4}">
                 <adec:decorative xmlns:adec="http://schemas.microsoft.com/office/drawing/2017/decorative" val="1"/>
@@ -16807,18 +16975,18 @@
         </p:nvGrpSpPr>
         <p:grpSpPr>
           <a:xfrm>
-            <a:off x="295910" y="9653937"/>
-            <a:ext cx="1305101" cy="163205"/>
+            <a:off x="5250199" y="245911"/>
+            <a:ext cx="1305102" cy="163205"/>
             <a:chOff x="295910" y="9653937"/>
-            <a:chExt cx="1305101" cy="163205"/>
+            <a:chExt cx="1305102" cy="163205"/>
           </a:xfrm>
         </p:grpSpPr>
         <p:pic>
           <p:nvPicPr>
-            <p:cNvPr id="30" name="Picture 29">
+            <p:cNvPr id="36" name="Picture 35">
               <a:extLst>
                 <a:ext uri="{FF2B5EF4-FFF2-40B4-BE49-F238E27FC236}">
-                  <a16:creationId xmlns:a16="http://schemas.microsoft.com/office/drawing/2014/main" id="{9316052A-01CB-6BE7-22D0-7B5ECD0ABD2D}"/>
+                  <a16:creationId xmlns:a16="http://schemas.microsoft.com/office/drawing/2014/main" id="{B26E2D6C-CF9B-B327-0930-27598F435701}"/>
                 </a:ext>
                 <a:ext uri="{C183D7F6-B498-43B3-948B-1728B52AA6E4}">
                   <adec:decorative xmlns:adec="http://schemas.microsoft.com/office/drawing/2017/decorative" val="1"/>
@@ -16854,10 +17022,10 @@
         </p:pic>
         <p:grpSp>
           <p:nvGrpSpPr>
-            <p:cNvPr id="31" name="Group 30">
+            <p:cNvPr id="37" name="Group 36">
               <a:extLst>
                 <a:ext uri="{FF2B5EF4-FFF2-40B4-BE49-F238E27FC236}">
-                  <a16:creationId xmlns:a16="http://schemas.microsoft.com/office/drawing/2014/main" id="{DDA9A306-57AF-8DD3-1688-5E3302D0891D}"/>
+                  <a16:creationId xmlns:a16="http://schemas.microsoft.com/office/drawing/2014/main" id="{E6213FE8-67DD-968B-D2CF-D0C3BF430F95}"/>
                 </a:ext>
                 <a:ext uri="{C183D7F6-B498-43B3-948B-1728B52AA6E4}">
                   <adec:decorative xmlns:adec="http://schemas.microsoft.com/office/drawing/2017/decorative" val="1"/>
@@ -16869,7 +17037,7 @@
           </p:nvGrpSpPr>
           <p:grpSpPr>
             <a:xfrm>
-              <a:off x="1226496" y="9675214"/>
+              <a:off x="1226497" y="9675214"/>
               <a:ext cx="374515" cy="120649"/>
               <a:chOff x="4063999" y="4953000"/>
               <a:chExt cx="1892301" cy="609600"/>
@@ -16877,10 +17045,10 @@
           </p:grpSpPr>
           <p:pic>
             <p:nvPicPr>
-              <p:cNvPr id="32" name="Picture 31">
+              <p:cNvPr id="38" name="Picture 37">
                 <a:extLst>
                   <a:ext uri="{FF2B5EF4-FFF2-40B4-BE49-F238E27FC236}">
-                    <a16:creationId xmlns:a16="http://schemas.microsoft.com/office/drawing/2014/main" id="{559A8957-2BBE-CEFC-DD45-2F8FCC36C0D5}"/>
+                    <a16:creationId xmlns:a16="http://schemas.microsoft.com/office/drawing/2014/main" id="{BA99970C-340B-666F-A12D-6C57A86B46D0}"/>
                   </a:ext>
                 </a:extLst>
               </p:cNvPr>
@@ -16907,10 +17075,10 @@
           </p:pic>
           <p:pic>
             <p:nvPicPr>
-              <p:cNvPr id="33" name="Picture 32">
+              <p:cNvPr id="39" name="Picture 38">
                 <a:extLst>
                   <a:ext uri="{FF2B5EF4-FFF2-40B4-BE49-F238E27FC236}">
-                    <a16:creationId xmlns:a16="http://schemas.microsoft.com/office/drawing/2014/main" id="{8D33CC6E-8A5B-06F5-0B04-BCFAAD9D970B}"/>
+                    <a16:creationId xmlns:a16="http://schemas.microsoft.com/office/drawing/2014/main" id="{875A85D1-1626-4CF5-0CEC-24E2E2ED457C}"/>
                   </a:ext>
                 </a:extLst>
               </p:cNvPr>
@@ -16937,10 +17105,10 @@
           </p:pic>
           <p:pic>
             <p:nvPicPr>
-              <p:cNvPr id="34" name="Picture 33">
+              <p:cNvPr id="40" name="Picture 39">
                 <a:extLst>
                   <a:ext uri="{FF2B5EF4-FFF2-40B4-BE49-F238E27FC236}">
-                    <a16:creationId xmlns:a16="http://schemas.microsoft.com/office/drawing/2014/main" id="{0EB7CB5A-A1DC-790A-6912-F9F8EB5B7BA6}"/>
+                    <a16:creationId xmlns:a16="http://schemas.microsoft.com/office/drawing/2014/main" id="{584E6BC5-6475-A8D1-5888-00B7FA876CDD}"/>
                   </a:ext>
                 </a:extLst>
               </p:cNvPr>
@@ -21724,10 +21892,10 @@
       </p:sp>
       <p:grpSp>
         <p:nvGrpSpPr>
-          <p:cNvPr id="21" name="Group 20">
+          <p:cNvPr id="27" name="Group 26">
             <a:extLst>
               <a:ext uri="{FF2B5EF4-FFF2-40B4-BE49-F238E27FC236}">
-                <a16:creationId xmlns:a16="http://schemas.microsoft.com/office/drawing/2014/main" id="{71B526BD-6371-A85A-645D-752D1E0D7EEA}"/>
+                <a16:creationId xmlns:a16="http://schemas.microsoft.com/office/drawing/2014/main" id="{59D64B8B-3BE8-9B29-CE71-21B765E22BF5}"/>
               </a:ext>
               <a:ext uri="{C183D7F6-B498-43B3-948B-1728B52AA6E4}">
                 <adec:decorative xmlns:adec="http://schemas.microsoft.com/office/drawing/2017/decorative" val="1"/>
@@ -21739,18 +21907,18 @@
         </p:nvGrpSpPr>
         <p:grpSpPr>
           <a:xfrm>
-            <a:off x="295910" y="9653937"/>
-            <a:ext cx="1305101" cy="163205"/>
+            <a:off x="5250199" y="245911"/>
+            <a:ext cx="1305102" cy="163205"/>
             <a:chOff x="295910" y="9653937"/>
-            <a:chExt cx="1305101" cy="163205"/>
+            <a:chExt cx="1305102" cy="163205"/>
           </a:xfrm>
         </p:grpSpPr>
         <p:pic>
           <p:nvPicPr>
-            <p:cNvPr id="22" name="Picture 21">
+            <p:cNvPr id="28" name="Picture 27">
               <a:extLst>
                 <a:ext uri="{FF2B5EF4-FFF2-40B4-BE49-F238E27FC236}">
-                  <a16:creationId xmlns:a16="http://schemas.microsoft.com/office/drawing/2014/main" id="{2AD64ABE-B9C8-3980-2BBC-5D1AFA5615C0}"/>
+                  <a16:creationId xmlns:a16="http://schemas.microsoft.com/office/drawing/2014/main" id="{DB493EE4-26F2-304E-5349-5D61B8EB313B}"/>
                 </a:ext>
                 <a:ext uri="{C183D7F6-B498-43B3-948B-1728B52AA6E4}">
                   <adec:decorative xmlns:adec="http://schemas.microsoft.com/office/drawing/2017/decorative" val="1"/>
@@ -21786,10 +21954,10 @@
         </p:pic>
         <p:grpSp>
           <p:nvGrpSpPr>
-            <p:cNvPr id="23" name="Group 22">
+            <p:cNvPr id="29" name="Group 28">
               <a:extLst>
                 <a:ext uri="{FF2B5EF4-FFF2-40B4-BE49-F238E27FC236}">
-                  <a16:creationId xmlns:a16="http://schemas.microsoft.com/office/drawing/2014/main" id="{55A46F05-4DB7-5D63-1824-3657FB16D564}"/>
+                  <a16:creationId xmlns:a16="http://schemas.microsoft.com/office/drawing/2014/main" id="{25468CBA-47B9-943E-6F16-AB244B799FA0}"/>
                 </a:ext>
                 <a:ext uri="{C183D7F6-B498-43B3-948B-1728B52AA6E4}">
                   <adec:decorative xmlns:adec="http://schemas.microsoft.com/office/drawing/2017/decorative" val="1"/>
@@ -21801,7 +21969,7 @@
           </p:nvGrpSpPr>
           <p:grpSpPr>
             <a:xfrm>
-              <a:off x="1226496" y="9675214"/>
+              <a:off x="1226497" y="9675214"/>
               <a:ext cx="374515" cy="120649"/>
               <a:chOff x="4063999" y="4953000"/>
               <a:chExt cx="1892301" cy="609600"/>
@@ -21809,10 +21977,10 @@
           </p:grpSpPr>
           <p:pic>
             <p:nvPicPr>
-              <p:cNvPr id="24" name="Picture 23">
+              <p:cNvPr id="30" name="Picture 29">
                 <a:extLst>
                   <a:ext uri="{FF2B5EF4-FFF2-40B4-BE49-F238E27FC236}">
-                    <a16:creationId xmlns:a16="http://schemas.microsoft.com/office/drawing/2014/main" id="{B74F1016-1E6E-5106-68FB-F7DC59630E78}"/>
+                    <a16:creationId xmlns:a16="http://schemas.microsoft.com/office/drawing/2014/main" id="{F87A6AFA-73EA-424C-EF17-1D268F761A7A}"/>
                   </a:ext>
                 </a:extLst>
               </p:cNvPr>
@@ -21839,10 +22007,10 @@
           </p:pic>
           <p:pic>
             <p:nvPicPr>
-              <p:cNvPr id="25" name="Picture 24">
+              <p:cNvPr id="31" name="Picture 30">
                 <a:extLst>
                   <a:ext uri="{FF2B5EF4-FFF2-40B4-BE49-F238E27FC236}">
-                    <a16:creationId xmlns:a16="http://schemas.microsoft.com/office/drawing/2014/main" id="{7A2680C8-0477-8E6B-0C6E-2098C7DDE171}"/>
+                    <a16:creationId xmlns:a16="http://schemas.microsoft.com/office/drawing/2014/main" id="{4F97DE03-1C2A-0F34-A473-BEA2F6ACA809}"/>
                   </a:ext>
                 </a:extLst>
               </p:cNvPr>
@@ -21869,10 +22037,10 @@
           </p:pic>
           <p:pic>
             <p:nvPicPr>
-              <p:cNvPr id="26" name="Picture 25">
+              <p:cNvPr id="32" name="Picture 31">
                 <a:extLst>
                   <a:ext uri="{FF2B5EF4-FFF2-40B4-BE49-F238E27FC236}">
-                    <a16:creationId xmlns:a16="http://schemas.microsoft.com/office/drawing/2014/main" id="{7D001D33-4752-A77A-83E8-A907A2D78282}"/>
+                    <a16:creationId xmlns:a16="http://schemas.microsoft.com/office/drawing/2014/main" id="{5AB9180D-FED1-5990-49F3-4924A43AF039}"/>
                   </a:ext>
                 </a:extLst>
               </p:cNvPr>
@@ -23594,10 +23762,10 @@
       </p:sp>
       <p:grpSp>
         <p:nvGrpSpPr>
-          <p:cNvPr id="9" name="Group 8">
+          <p:cNvPr id="15" name="Group 14">
             <a:extLst>
               <a:ext uri="{FF2B5EF4-FFF2-40B4-BE49-F238E27FC236}">
-                <a16:creationId xmlns:a16="http://schemas.microsoft.com/office/drawing/2014/main" id="{53C28EC9-A810-78C9-2CC3-C3D888247711}"/>
+                <a16:creationId xmlns:a16="http://schemas.microsoft.com/office/drawing/2014/main" id="{5E2555FA-EB1C-5ABA-4CFC-B47503D6F393}"/>
               </a:ext>
               <a:ext uri="{C183D7F6-B498-43B3-948B-1728B52AA6E4}">
                 <adec:decorative xmlns:adec="http://schemas.microsoft.com/office/drawing/2017/decorative" val="1"/>
@@ -23609,18 +23777,18 @@
         </p:nvGrpSpPr>
         <p:grpSpPr>
           <a:xfrm>
-            <a:off x="295910" y="9653937"/>
-            <a:ext cx="1305101" cy="163205"/>
+            <a:off x="5250199" y="245911"/>
+            <a:ext cx="1305102" cy="163205"/>
             <a:chOff x="295910" y="9653937"/>
-            <a:chExt cx="1305101" cy="163205"/>
+            <a:chExt cx="1305102" cy="163205"/>
           </a:xfrm>
         </p:grpSpPr>
         <p:pic>
           <p:nvPicPr>
-            <p:cNvPr id="10" name="Picture 9">
+            <p:cNvPr id="16" name="Picture 15">
               <a:extLst>
                 <a:ext uri="{FF2B5EF4-FFF2-40B4-BE49-F238E27FC236}">
-                  <a16:creationId xmlns:a16="http://schemas.microsoft.com/office/drawing/2014/main" id="{94EA92C3-6807-4003-235C-B0566638AEC4}"/>
+                  <a16:creationId xmlns:a16="http://schemas.microsoft.com/office/drawing/2014/main" id="{78313FCB-D2E6-ED59-D9EF-28395F98C9EF}"/>
                 </a:ext>
                 <a:ext uri="{C183D7F6-B498-43B3-948B-1728B52AA6E4}">
                   <adec:decorative xmlns:adec="http://schemas.microsoft.com/office/drawing/2017/decorative" val="1"/>
@@ -23656,10 +23824,10 @@
         </p:pic>
         <p:grpSp>
           <p:nvGrpSpPr>
-            <p:cNvPr id="11" name="Group 10">
+            <p:cNvPr id="17" name="Group 16">
               <a:extLst>
                 <a:ext uri="{FF2B5EF4-FFF2-40B4-BE49-F238E27FC236}">
-                  <a16:creationId xmlns:a16="http://schemas.microsoft.com/office/drawing/2014/main" id="{919F3083-E189-5940-EBA5-0C16C2C2BC68}"/>
+                  <a16:creationId xmlns:a16="http://schemas.microsoft.com/office/drawing/2014/main" id="{263B43C7-ED10-BA2F-F7E4-6870680F946C}"/>
                 </a:ext>
                 <a:ext uri="{C183D7F6-B498-43B3-948B-1728B52AA6E4}">
                   <adec:decorative xmlns:adec="http://schemas.microsoft.com/office/drawing/2017/decorative" val="1"/>
@@ -23671,7 +23839,7 @@
           </p:nvGrpSpPr>
           <p:grpSpPr>
             <a:xfrm>
-              <a:off x="1226496" y="9675214"/>
+              <a:off x="1226497" y="9675214"/>
               <a:ext cx="374515" cy="120649"/>
               <a:chOff x="4063999" y="4953000"/>
               <a:chExt cx="1892301" cy="609600"/>
@@ -23679,10 +23847,10 @@
           </p:grpSpPr>
           <p:pic>
             <p:nvPicPr>
-              <p:cNvPr id="12" name="Picture 11">
+              <p:cNvPr id="18" name="Picture 17">
                 <a:extLst>
                   <a:ext uri="{FF2B5EF4-FFF2-40B4-BE49-F238E27FC236}">
-                    <a16:creationId xmlns:a16="http://schemas.microsoft.com/office/drawing/2014/main" id="{4F301108-C62C-1822-247D-0E523A44B8BD}"/>
+                    <a16:creationId xmlns:a16="http://schemas.microsoft.com/office/drawing/2014/main" id="{3A437B38-3056-10E3-B300-5E49CE1608C3}"/>
                   </a:ext>
                 </a:extLst>
               </p:cNvPr>
@@ -23709,10 +23877,10 @@
           </p:pic>
           <p:pic>
             <p:nvPicPr>
-              <p:cNvPr id="13" name="Picture 12">
+              <p:cNvPr id="19" name="Picture 18">
                 <a:extLst>
                   <a:ext uri="{FF2B5EF4-FFF2-40B4-BE49-F238E27FC236}">
-                    <a16:creationId xmlns:a16="http://schemas.microsoft.com/office/drawing/2014/main" id="{C9E2842B-005D-3695-07DD-840EE4F81FBC}"/>
+                    <a16:creationId xmlns:a16="http://schemas.microsoft.com/office/drawing/2014/main" id="{4BE9FBC5-DD26-DC12-ABB1-0D742F035C7C}"/>
                   </a:ext>
                 </a:extLst>
               </p:cNvPr>
@@ -23739,10 +23907,10 @@
           </p:pic>
           <p:pic>
             <p:nvPicPr>
-              <p:cNvPr id="14" name="Picture 13">
+              <p:cNvPr id="20" name="Picture 19">
                 <a:extLst>
                   <a:ext uri="{FF2B5EF4-FFF2-40B4-BE49-F238E27FC236}">
-                    <a16:creationId xmlns:a16="http://schemas.microsoft.com/office/drawing/2014/main" id="{7644ECFB-139C-2D96-9E8B-48B1F3220AEF}"/>
+                    <a16:creationId xmlns:a16="http://schemas.microsoft.com/office/drawing/2014/main" id="{D4267AC5-DD00-75C1-DF8F-82D64536605D}"/>
                   </a:ext>
                 </a:extLst>
               </p:cNvPr>
@@ -24418,6 +24586,26 @@
 </file>
 
 <file path=customXml/item1.xml><?xml version="1.0" encoding="utf-8"?>
+<?mso-contentType ?>
+<FormTemplates xmlns="http://schemas.microsoft.com/sharepoint/v3/contenttype/forms">
+  <Display>DocumentLibraryForm</Display>
+  <Edit>DocumentLibraryForm</Edit>
+  <New>DocumentLibraryForm</New>
+</FormTemplates>
+</file>
+
+<file path=customXml/item2.xml><?xml version="1.0" encoding="utf-8"?>
+<p:properties xmlns:p="http://schemas.microsoft.com/office/2006/metadata/properties" xmlns:xsi="http://www.w3.org/2001/XMLSchema-instance" xmlns:pc="http://schemas.microsoft.com/office/infopath/2007/PartnerControls">
+  <documentManagement>
+    <lcf76f155ced4ddcb4097134ff3c332f xmlns="da1b7603-f8b8-47c9-9682-dc6aa8e9acd7">
+      <Terms xmlns="http://schemas.microsoft.com/office/infopath/2007/PartnerControls"/>
+    </lcf76f155ced4ddcb4097134ff3c332f>
+    <TaxCatchAll xmlns="94bcf745-830c-42f4-885c-a1d7342e6e36" xsi:nil="true"/>
+  </documentManagement>
+</p:properties>
+</file>
+
+<file path=customXml/item3.xml><?xml version="1.0" encoding="utf-8"?>
 <ct:contentTypeSchema xmlns:ct="http://schemas.microsoft.com/office/2006/metadata/contentType" xmlns:ma="http://schemas.microsoft.com/office/2006/metadata/properties/metaAttributes" ct:_="" ma:_="" ma:contentTypeName="Dokument" ma:contentTypeID="0x0101009BF7B09DBF6D7B4DA35692C22AFAF86F" ma:contentTypeVersion="16" ma:contentTypeDescription="Ein neues Dokument erstellen." ma:contentTypeScope="" ma:versionID="a5f25a2d2f3966261c4134713dfa4526">
   <xsd:schema xmlns:xsd="http://www.w3.org/2001/XMLSchema" xmlns:xs="http://www.w3.org/2001/XMLSchema" xmlns:p="http://schemas.microsoft.com/office/2006/metadata/properties" xmlns:ns2="da1b7603-f8b8-47c9-9682-dc6aa8e9acd7" xmlns:ns3="94bcf745-830c-42f4-885c-a1d7342e6e36" targetNamespace="http://schemas.microsoft.com/office/2006/metadata/properties" ma:root="true" ma:fieldsID="3bd5b08873ef7f837dc9b940f7d80505" ns2:_="" ns3:_="">
     <xsd:import namespace="da1b7603-f8b8-47c9-9682-dc6aa8e9acd7"/>
@@ -24660,41 +24848,10 @@
 </ct:contentTypeSchema>
 </file>
 
-<file path=customXml/item2.xml><?xml version="1.0" encoding="utf-8"?>
-<p:properties xmlns:p="http://schemas.microsoft.com/office/2006/metadata/properties" xmlns:xsi="http://www.w3.org/2001/XMLSchema-instance" xmlns:pc="http://schemas.microsoft.com/office/infopath/2007/PartnerControls">
-  <documentManagement>
-    <lcf76f155ced4ddcb4097134ff3c332f xmlns="da1b7603-f8b8-47c9-9682-dc6aa8e9acd7">
-      <Terms xmlns="http://schemas.microsoft.com/office/infopath/2007/PartnerControls"/>
-    </lcf76f155ced4ddcb4097134ff3c332f>
-    <TaxCatchAll xmlns="94bcf745-830c-42f4-885c-a1d7342e6e36" xsi:nil="true"/>
-  </documentManagement>
-</p:properties>
-</file>
-
-<file path=customXml/item3.xml><?xml version="1.0" encoding="utf-8"?>
-<?mso-contentType ?>
-<FormTemplates xmlns="http://schemas.microsoft.com/sharepoint/v3/contenttype/forms">
-  <Display>DocumentLibraryForm</Display>
-  <Edit>DocumentLibraryForm</Edit>
-  <New>DocumentLibraryForm</New>
-</FormTemplates>
-</file>
-
 <file path=customXml/itemProps1.xml><?xml version="1.0" encoding="utf-8"?>
-<ds:datastoreItem xmlns:ds="http://schemas.openxmlformats.org/officeDocument/2006/customXml" ds:itemID="{6B56FAFF-97DD-4CFB-A93B-18519AA4E99C}">
+<ds:datastoreItem xmlns:ds="http://schemas.openxmlformats.org/officeDocument/2006/customXml" ds:itemID="{329A8B4E-FDB2-442F-A1FE-63815B7A5BA7}">
   <ds:schemaRefs>
-    <ds:schemaRef ds:uri="http://schemas.microsoft.com/office/2006/metadata/contentType"/>
-    <ds:schemaRef ds:uri="http://schemas.microsoft.com/office/2006/metadata/properties/metaAttributes"/>
-    <ds:schemaRef ds:uri="http://www.w3.org/2001/XMLSchema"/>
-    <ds:schemaRef ds:uri="http://schemas.microsoft.com/office/2006/metadata/properties"/>
-    <ds:schemaRef ds:uri="da1b7603-f8b8-47c9-9682-dc6aa8e9acd7"/>
-    <ds:schemaRef ds:uri="94bcf745-830c-42f4-885c-a1d7342e6e36"/>
-    <ds:schemaRef ds:uri="http://schemas.microsoft.com/office/2006/documentManagement/types"/>
-    <ds:schemaRef ds:uri="http://schemas.microsoft.com/office/infopath/2007/PartnerControls"/>
-    <ds:schemaRef ds:uri="http://schemas.openxmlformats.org/package/2006/metadata/core-properties"/>
-    <ds:schemaRef ds:uri="http://purl.org/dc/elements/1.1/"/>
-    <ds:schemaRef ds:uri="http://purl.org/dc/terms/"/>
-    <ds:schemaRef ds:uri="http://schemas.microsoft.com/internal/obd"/>
+    <ds:schemaRef ds:uri="http://schemas.microsoft.com/sharepoint/v3/contenttype/forms"/>
   </ds:schemaRefs>
 </ds:datastoreItem>
 </file>
@@ -24717,9 +24874,20 @@
 </file>
 
 <file path=customXml/itemProps3.xml><?xml version="1.0" encoding="utf-8"?>
-<ds:datastoreItem xmlns:ds="http://schemas.openxmlformats.org/officeDocument/2006/customXml" ds:itemID="{329A8B4E-FDB2-442F-A1FE-63815B7A5BA7}">
+<ds:datastoreItem xmlns:ds="http://schemas.openxmlformats.org/officeDocument/2006/customXml" ds:itemID="{6B56FAFF-97DD-4CFB-A93B-18519AA4E99C}">
   <ds:schemaRefs>
-    <ds:schemaRef ds:uri="http://schemas.microsoft.com/sharepoint/v3/contenttype/forms"/>
+    <ds:schemaRef ds:uri="http://schemas.microsoft.com/office/2006/metadata/contentType"/>
+    <ds:schemaRef ds:uri="http://schemas.microsoft.com/office/2006/metadata/properties/metaAttributes"/>
+    <ds:schemaRef ds:uri="http://www.w3.org/2001/XMLSchema"/>
+    <ds:schemaRef ds:uri="http://schemas.microsoft.com/office/2006/metadata/properties"/>
+    <ds:schemaRef ds:uri="da1b7603-f8b8-47c9-9682-dc6aa8e9acd7"/>
+    <ds:schemaRef ds:uri="94bcf745-830c-42f4-885c-a1d7342e6e36"/>
+    <ds:schemaRef ds:uri="http://schemas.microsoft.com/office/2006/documentManagement/types"/>
+    <ds:schemaRef ds:uri="http://schemas.microsoft.com/office/infopath/2007/PartnerControls"/>
+    <ds:schemaRef ds:uri="http://schemas.openxmlformats.org/package/2006/metadata/core-properties"/>
+    <ds:schemaRef ds:uri="http://purl.org/dc/elements/1.1/"/>
+    <ds:schemaRef ds:uri="http://purl.org/dc/terms/"/>
+    <ds:schemaRef ds:uri="http://schemas.microsoft.com/internal/obd"/>
   </ds:schemaRefs>
 </ds:datastoreItem>
 </file>
</xml_diff>